<commit_message>
Site updated: 2020-11-04 23:13:25
</commit_message>
<xml_diff>
--- a/other/204实验.pptx
+++ b/other/204实验.pptx
@@ -20,6 +20,7 @@
     <p:sldId id="269" r:id="rId14"/>
     <p:sldId id="273" r:id="rId15"/>
     <p:sldId id="272" r:id="rId16"/>
+    <p:sldId id="274" r:id="rId17"/>
   </p:sldIdLst>
   <p:sldSz cx="12192000" cy="6858000"/>
   <p:notesSz cx="6858000" cy="9144000"/>
@@ -255,7 +256,7 @@
           <a:p>
             <a:fld id="{C1204EAE-C964-486C-9112-A587BFBBD611}" type="datetimeFigureOut">
               <a:rPr lang="zh-CN" altLang="en-US" smtClean="0"/>
-              <a:t>2020/11/3</a:t>
+              <a:t>2020/11/4</a:t>
             </a:fld>
             <a:endParaRPr lang="zh-CN" altLang="en-US"/>
           </a:p>
@@ -418,7 +419,7 @@
           <a:p>
             <a:fld id="{C1204EAE-C964-486C-9112-A587BFBBD611}" type="datetimeFigureOut">
               <a:rPr lang="zh-CN" altLang="en-US" smtClean="0"/>
-              <a:t>2020/11/3</a:t>
+              <a:t>2020/11/4</a:t>
             </a:fld>
             <a:endParaRPr lang="zh-CN" altLang="en-US"/>
           </a:p>
@@ -591,7 +592,7 @@
           <a:p>
             <a:fld id="{C1204EAE-C964-486C-9112-A587BFBBD611}" type="datetimeFigureOut">
               <a:rPr lang="zh-CN" altLang="en-US" smtClean="0"/>
-              <a:t>2020/11/3</a:t>
+              <a:t>2020/11/4</a:t>
             </a:fld>
             <a:endParaRPr lang="zh-CN" altLang="en-US"/>
           </a:p>
@@ -754,7 +755,7 @@
           <a:p>
             <a:fld id="{C1204EAE-C964-486C-9112-A587BFBBD611}" type="datetimeFigureOut">
               <a:rPr lang="zh-CN" altLang="en-US" smtClean="0"/>
-              <a:t>2020/11/3</a:t>
+              <a:t>2020/11/4</a:t>
             </a:fld>
             <a:endParaRPr lang="zh-CN" altLang="en-US"/>
           </a:p>
@@ -994,7 +995,7 @@
           <a:p>
             <a:fld id="{C1204EAE-C964-486C-9112-A587BFBBD611}" type="datetimeFigureOut">
               <a:rPr lang="zh-CN" altLang="en-US" smtClean="0"/>
-              <a:t>2020/11/3</a:t>
+              <a:t>2020/11/4</a:t>
             </a:fld>
             <a:endParaRPr lang="zh-CN" altLang="en-US"/>
           </a:p>
@@ -1218,7 +1219,7 @@
           <a:p>
             <a:fld id="{C1204EAE-C964-486C-9112-A587BFBBD611}" type="datetimeFigureOut">
               <a:rPr lang="zh-CN" altLang="en-US" smtClean="0"/>
-              <a:t>2020/11/3</a:t>
+              <a:t>2020/11/4</a:t>
             </a:fld>
             <a:endParaRPr lang="zh-CN" altLang="en-US"/>
           </a:p>
@@ -1577,7 +1578,7 @@
           <a:p>
             <a:fld id="{C1204EAE-C964-486C-9112-A587BFBBD611}" type="datetimeFigureOut">
               <a:rPr lang="zh-CN" altLang="en-US" smtClean="0"/>
-              <a:t>2020/11/3</a:t>
+              <a:t>2020/11/4</a:t>
             </a:fld>
             <a:endParaRPr lang="zh-CN" altLang="en-US"/>
           </a:p>
@@ -1689,7 +1690,7 @@
           <a:p>
             <a:fld id="{C1204EAE-C964-486C-9112-A587BFBBD611}" type="datetimeFigureOut">
               <a:rPr lang="zh-CN" altLang="en-US" smtClean="0"/>
-              <a:t>2020/11/3</a:t>
+              <a:t>2020/11/4</a:t>
             </a:fld>
             <a:endParaRPr lang="zh-CN" altLang="en-US"/>
           </a:p>
@@ -1779,7 +1780,7 @@
           <a:p>
             <a:fld id="{C1204EAE-C964-486C-9112-A587BFBBD611}" type="datetimeFigureOut">
               <a:rPr lang="zh-CN" altLang="en-US" smtClean="0"/>
-              <a:t>2020/11/3</a:t>
+              <a:t>2020/11/4</a:t>
             </a:fld>
             <a:endParaRPr lang="zh-CN" altLang="en-US"/>
           </a:p>
@@ -2049,7 +2050,7 @@
           <a:p>
             <a:fld id="{C1204EAE-C964-486C-9112-A587BFBBD611}" type="datetimeFigureOut">
               <a:rPr lang="zh-CN" altLang="en-US" smtClean="0"/>
-              <a:t>2020/11/3</a:t>
+              <a:t>2020/11/4</a:t>
             </a:fld>
             <a:endParaRPr lang="zh-CN" altLang="en-US"/>
           </a:p>
@@ -2296,7 +2297,7 @@
           <a:p>
             <a:fld id="{C1204EAE-C964-486C-9112-A587BFBBD611}" type="datetimeFigureOut">
               <a:rPr lang="zh-CN" altLang="en-US" smtClean="0"/>
-              <a:t>2020/11/3</a:t>
+              <a:t>2020/11/4</a:t>
             </a:fld>
             <a:endParaRPr lang="zh-CN" altLang="en-US"/>
           </a:p>
@@ -2502,7 +2503,7 @@
           <a:p>
             <a:fld id="{C1204EAE-C964-486C-9112-A587BFBBD611}" type="datetimeFigureOut">
               <a:rPr lang="zh-CN" altLang="en-US" smtClean="0"/>
-              <a:t>2020/11/3</a:t>
+              <a:t>2020/11/4</a:t>
             </a:fld>
             <a:endParaRPr lang="zh-CN" altLang="en-US"/>
           </a:p>
@@ -3138,7 +3139,7 @@
                   </a:outerShdw>
                 </a:effectLst>
               </a:rPr>
-              <a:t>第六步：设置无线</a:t>
+              <a:t>设置无线</a:t>
             </a:r>
             <a:r>
               <a:rPr lang="en-US" altLang="zh-CN" sz="1600" b="1" dirty="0">
@@ -3650,8 +3651,8 @@
         </p:blipFill>
         <p:spPr>
           <a:xfrm>
-            <a:off x="2312368" y="1351178"/>
-            <a:ext cx="7163800" cy="2038635"/>
+            <a:off x="2312368" y="740837"/>
+            <a:ext cx="6026289" cy="1714928"/>
           </a:xfrm>
           <a:prstGeom prst="rect">
             <a:avLst/>
@@ -3686,8 +3687,8 @@
         </p:blipFill>
         <p:spPr>
           <a:xfrm>
-            <a:off x="1183454" y="3682253"/>
-            <a:ext cx="3801005" cy="2200582"/>
+            <a:off x="1987097" y="2833498"/>
+            <a:ext cx="2977486" cy="1723808"/>
           </a:xfrm>
           <a:prstGeom prst="rect">
             <a:avLst/>
@@ -3722,8 +3723,8 @@
         </p:blipFill>
         <p:spPr>
           <a:xfrm>
-            <a:off x="5799689" y="3844200"/>
-            <a:ext cx="5627415" cy="2038635"/>
+            <a:off x="5400815" y="2820743"/>
+            <a:ext cx="4758253" cy="1723765"/>
           </a:xfrm>
           <a:prstGeom prst="rect">
             <a:avLst/>
@@ -3748,19 +3749,19 @@
         </p:nvSpPr>
         <p:spPr>
           <a:xfrm>
-            <a:off x="1806180" y="480213"/>
-            <a:ext cx="7987018" cy="740471"/>
+            <a:off x="2312368" y="480214"/>
+            <a:ext cx="7480830" cy="207684"/>
           </a:xfrm>
         </p:spPr>
         <p:txBody>
           <a:bodyPr>
-            <a:normAutofit/>
+            <a:noAutofit/>
           </a:bodyPr>
           <a:lstStyle/>
           <a:p>
             <a:pPr algn="ctr"/>
             <a:r>
-              <a:rPr lang="zh-CN" altLang="en-US" sz="3600" b="1" dirty="0">
+              <a:rPr lang="zh-CN" altLang="en-US" sz="1400" b="1" dirty="0">
                 <a:solidFill>
                   <a:schemeClr val="tx2">
                     <a:lumMod val="60000"/>
@@ -3776,6 +3777,135 @@
                 </a:effectLst>
               </a:rPr>
               <a:t>回到开始，看一看原理</a:t>
+            </a:r>
+          </a:p>
+        </p:txBody>
+      </p:sp>
+      <p:sp>
+        <p:nvSpPr>
+          <p:cNvPr id="3" name="文本框 2">
+            <a:extLst>
+              <a:ext uri="{FF2B5EF4-FFF2-40B4-BE49-F238E27FC236}">
+                <a16:creationId xmlns:a16="http://schemas.microsoft.com/office/drawing/2014/main" id="{95732195-D6C7-4FFC-BCC7-BF6B876A68D3}"/>
+              </a:ext>
+            </a:extLst>
+          </p:cNvPr>
+          <p:cNvSpPr txBox="1"/>
+          <p:nvPr/>
+        </p:nvSpPr>
+        <p:spPr>
+          <a:xfrm>
+            <a:off x="2057802" y="4840448"/>
+            <a:ext cx="6686026" cy="646331"/>
+          </a:xfrm>
+          <a:prstGeom prst="rect">
+            <a:avLst/>
+          </a:prstGeom>
+          <a:noFill/>
+        </p:spPr>
+        <p:txBody>
+          <a:bodyPr wrap="square" rtlCol="0">
+            <a:spAutoFit/>
+          </a:bodyPr>
+          <a:lstStyle/>
+          <a:p>
+            <a:r>
+              <a:rPr lang="zh-CN" altLang="en-US" dirty="0">
+                <a:solidFill>
+                  <a:schemeClr val="accent1">
+                    <a:lumMod val="60000"/>
+                    <a:lumOff val="40000"/>
+                  </a:schemeClr>
+                </a:solidFill>
+              </a:rPr>
+              <a:t>经过实验：访问</a:t>
+            </a:r>
+            <a:r>
+              <a:rPr lang="en-US" altLang="zh-CN" dirty="0">
+                <a:solidFill>
+                  <a:schemeClr val="accent1">
+                    <a:lumMod val="60000"/>
+                    <a:lumOff val="40000"/>
+                  </a:schemeClr>
+                </a:solidFill>
+              </a:rPr>
+              <a:t>192.168.1.11 </a:t>
+            </a:r>
+            <a:r>
+              <a:rPr lang="zh-CN" altLang="en-US" dirty="0">
+                <a:solidFill>
+                  <a:schemeClr val="accent1">
+                    <a:lumMod val="60000"/>
+                    <a:lumOff val="40000"/>
+                  </a:schemeClr>
+                </a:solidFill>
+              </a:rPr>
+              <a:t>速度和</a:t>
+            </a:r>
+            <a:r>
+              <a:rPr lang="en-US" altLang="zh-CN" dirty="0">
+                <a:solidFill>
+                  <a:schemeClr val="accent1">
+                    <a:lumMod val="60000"/>
+                    <a:lumOff val="40000"/>
+                  </a:schemeClr>
+                </a:solidFill>
+              </a:rPr>
+              <a:t>ping</a:t>
+            </a:r>
+            <a:r>
+              <a:rPr lang="zh-CN" altLang="en-US" dirty="0">
+                <a:solidFill>
+                  <a:schemeClr val="accent1">
+                    <a:lumMod val="60000"/>
+                    <a:lumOff val="40000"/>
+                  </a:schemeClr>
+                </a:solidFill>
+              </a:rPr>
+              <a:t>值符合无线的特征</a:t>
+            </a:r>
+            <a:endParaRPr lang="en-US" altLang="zh-CN" dirty="0">
+              <a:solidFill>
+                <a:schemeClr val="accent1">
+                  <a:lumMod val="60000"/>
+                  <a:lumOff val="40000"/>
+                </a:schemeClr>
+              </a:solidFill>
+            </a:endParaRPr>
+          </a:p>
+          <a:p>
+            <a:r>
+              <a:rPr lang="zh-CN" altLang="en-US" dirty="0">
+                <a:solidFill>
+                  <a:schemeClr val="accent1">
+                    <a:lumMod val="60000"/>
+                    <a:lumOff val="40000"/>
+                  </a:schemeClr>
+                </a:solidFill>
+              </a:rPr>
+              <a:t>访问</a:t>
+            </a:r>
+            <a:r>
+              <a:rPr lang="en-US" altLang="zh-CN" dirty="0">
+                <a:solidFill>
+                  <a:schemeClr val="accent1">
+                    <a:lumMod val="60000"/>
+                    <a:lumOff val="40000"/>
+                  </a:schemeClr>
+                </a:solidFill>
+              </a:rPr>
+              <a:t>192.168.1.21</a:t>
+            </a:r>
+            <a:r>
+              <a:rPr lang="zh-CN" altLang="en-US" dirty="0">
+                <a:solidFill>
+                  <a:schemeClr val="accent1">
+                    <a:lumMod val="60000"/>
+                    <a:lumOff val="40000"/>
+                  </a:schemeClr>
+                </a:solidFill>
+              </a:rPr>
+              <a:t>符合有线的特征</a:t>
             </a:r>
           </a:p>
         </p:txBody>
@@ -6564,6 +6694,157 @@
 </p:sld>
 </file>
 
+<file path=ppt/slides/slide16.xml><?xml version="1.0" encoding="utf-8"?>
+<p:sld xmlns:a="http://schemas.openxmlformats.org/drawingml/2006/main" xmlns:r="http://schemas.openxmlformats.org/officeDocument/2006/relationships" xmlns:p="http://schemas.openxmlformats.org/presentationml/2006/main">
+  <p:cSld>
+    <p:spTree>
+      <p:nvGrpSpPr>
+        <p:cNvPr id="1" name=""/>
+        <p:cNvGrpSpPr/>
+        <p:nvPr/>
+      </p:nvGrpSpPr>
+      <p:grpSpPr>
+        <a:xfrm>
+          <a:off x="0" y="0"/>
+          <a:ext cx="0" cy="0"/>
+          <a:chOff x="0" y="0"/>
+          <a:chExt cx="0" cy="0"/>
+        </a:xfrm>
+      </p:grpSpPr>
+      <p:sp>
+        <p:nvSpPr>
+          <p:cNvPr id="2" name="标题 1">
+            <a:extLst>
+              <a:ext uri="{FF2B5EF4-FFF2-40B4-BE49-F238E27FC236}">
+                <a16:creationId xmlns:a16="http://schemas.microsoft.com/office/drawing/2014/main" id="{740B20CF-492B-44C2-A9BC-62D0254C2950}"/>
+              </a:ext>
+            </a:extLst>
+          </p:cNvPr>
+          <p:cNvSpPr>
+            <a:spLocks noGrp="1"/>
+          </p:cNvSpPr>
+          <p:nvPr>
+            <p:ph type="title"/>
+          </p:nvPr>
+        </p:nvSpPr>
+        <p:spPr/>
+        <p:txBody>
+          <a:bodyPr/>
+          <a:lstStyle/>
+          <a:p>
+            <a:endParaRPr lang="zh-CN" altLang="en-US"/>
+          </a:p>
+        </p:txBody>
+      </p:sp>
+      <p:sp>
+        <p:nvSpPr>
+          <p:cNvPr id="3" name="内容占位符 2">
+            <a:extLst>
+              <a:ext uri="{FF2B5EF4-FFF2-40B4-BE49-F238E27FC236}">
+                <a16:creationId xmlns:a16="http://schemas.microsoft.com/office/drawing/2014/main" id="{37E3068F-0D97-4517-B94D-DA3F6044E09A}"/>
+              </a:ext>
+            </a:extLst>
+          </p:cNvPr>
+          <p:cNvSpPr>
+            <a:spLocks noGrp="1"/>
+          </p:cNvSpPr>
+          <p:nvPr>
+            <p:ph idx="1"/>
+          </p:nvPr>
+        </p:nvSpPr>
+        <p:spPr/>
+        <p:txBody>
+          <a:bodyPr/>
+          <a:lstStyle/>
+          <a:p>
+            <a:endParaRPr lang="zh-CN" altLang="en-US"/>
+          </a:p>
+        </p:txBody>
+      </p:sp>
+      <p:pic>
+        <p:nvPicPr>
+          <p:cNvPr id="5" name="图片 4">
+            <a:extLst>
+              <a:ext uri="{FF2B5EF4-FFF2-40B4-BE49-F238E27FC236}">
+                <a16:creationId xmlns:a16="http://schemas.microsoft.com/office/drawing/2014/main" id="{9433C9E0-DC12-4F84-B4BC-273077AAE645}"/>
+              </a:ext>
+            </a:extLst>
+          </p:cNvPr>
+          <p:cNvPicPr/>
+          <p:nvPr/>
+        </p:nvPicPr>
+        <p:blipFill>
+          <a:blip r:embed="rId2"/>
+          <a:stretch>
+            <a:fillRect/>
+          </a:stretch>
+        </p:blipFill>
+        <p:spPr>
+          <a:xfrm>
+            <a:off x="0" y="0"/>
+            <a:ext cx="12192000" cy="6858000"/>
+          </a:xfrm>
+          <a:prstGeom prst="rect">
+            <a:avLst/>
+          </a:prstGeom>
+        </p:spPr>
+      </p:pic>
+      <p:sp>
+        <p:nvSpPr>
+          <p:cNvPr id="6" name="文本框 5">
+            <a:extLst>
+              <a:ext uri="{FF2B5EF4-FFF2-40B4-BE49-F238E27FC236}">
+                <a16:creationId xmlns:a16="http://schemas.microsoft.com/office/drawing/2014/main" id="{508C8F11-3AC7-4D50-A3E3-F03C7A04E266}"/>
+              </a:ext>
+            </a:extLst>
+          </p:cNvPr>
+          <p:cNvSpPr txBox="1"/>
+          <p:nvPr/>
+        </p:nvSpPr>
+        <p:spPr>
+          <a:xfrm>
+            <a:off x="4388840" y="2659559"/>
+            <a:ext cx="3414320" cy="769441"/>
+          </a:xfrm>
+          <a:prstGeom prst="rect">
+            <a:avLst/>
+          </a:prstGeom>
+          <a:noFill/>
+        </p:spPr>
+        <p:txBody>
+          <a:bodyPr wrap="square" rtlCol="0">
+            <a:spAutoFit/>
+          </a:bodyPr>
+          <a:lstStyle/>
+          <a:p>
+            <a:pPr algn="ctr"/>
+            <a:r>
+              <a:rPr lang="zh-CN" altLang="en-US" sz="4400" dirty="0">
+                <a:solidFill>
+                  <a:schemeClr val="accent1">
+                    <a:lumMod val="60000"/>
+                    <a:lumOff val="40000"/>
+                  </a:schemeClr>
+                </a:solidFill>
+              </a:rPr>
+              <a:t>谢谢大家</a:t>
+            </a:r>
+          </a:p>
+        </p:txBody>
+      </p:sp>
+    </p:spTree>
+    <p:extLst>
+      <p:ext uri="{BB962C8B-B14F-4D97-AF65-F5344CB8AC3E}">
+        <p14:creationId xmlns:p14="http://schemas.microsoft.com/office/powerpoint/2010/main" val="884902377"/>
+      </p:ext>
+    </p:extLst>
+  </p:cSld>
+  <p:clrMapOvr>
+    <a:masterClrMapping/>
+  </p:clrMapOvr>
+</p:sld>
+</file>
+
 <file path=ppt/slides/slide2.xml><?xml version="1.0" encoding="utf-8"?>
 <p:sld xmlns:a="http://schemas.openxmlformats.org/drawingml/2006/main" xmlns:r="http://schemas.openxmlformats.org/officeDocument/2006/relationships" xmlns:p="http://schemas.openxmlformats.org/presentationml/2006/main">
   <p:cSld>
@@ -9464,7 +9745,7 @@
                   </a:outerShdw>
                 </a:effectLst>
               </a:rPr>
-              <a:t>第二步：确认两个电脑已经相连成功后，设置共享使两个队伍能够互相传输文件</a:t>
+              <a:t>确认两个电脑已经相连成功后，设置共享使两个队伍能够互相传输文件</a:t>
             </a:r>
           </a:p>
         </p:txBody>
@@ -9614,7 +9895,7 @@
                   </a:outerShdw>
                 </a:effectLst>
               </a:rPr>
-              <a:t>第四步：用一台电脑去访问另一台电脑已经共享的文件，然后将它传到自己这里，速度如图所示：</a:t>
+              <a:t>用一台电脑去访问另一台电脑已经共享的文件，然后将它传到自己这里，速度如图所示：</a:t>
             </a:r>
           </a:p>
         </p:txBody>
@@ -9778,7 +10059,7 @@
                   </a:outerShdw>
                 </a:effectLst>
               </a:rPr>
-              <a:t>第一步：两个电脑通过网线连接，一个</a:t>
+              <a:t>两个电脑通过网线连接，一个</a:t>
             </a:r>
             <a:r>
               <a:rPr lang="en-US" altLang="zh-CN" sz="1600" b="1" dirty="0">
@@ -10154,7 +10435,7 @@
                   </a:outerShdw>
                 </a:effectLst>
               </a:rPr>
-              <a:t>第五步：接下来测无线速度，用一个电脑去连另外一台电脑的热点，使两个电脑进行无线连接，如图所示：</a:t>
+              <a:t>接下来测无线速度，用一个电脑去连另外一台电脑的热点，使两个电脑进行无线连接，如图所示：</a:t>
             </a:r>
           </a:p>
         </p:txBody>
@@ -10327,7 +10608,7 @@
                   </a:outerShdw>
                 </a:effectLst>
               </a:rPr>
-              <a:t>第七步：重复用一台电脑去访问另一台电脑已经共享的文件，然后将它传到自己这里</a:t>
+              <a:t>重复用一台电脑去访问另一台电脑已经共享的文件，然后将它传到自己这里</a:t>
             </a:r>
           </a:p>
         </p:txBody>

</xml_diff>